<commit_message>
update stitch skills overview in MiniseLab workflow ppt
</commit_message>
<xml_diff>
--- a/presentations/MiniseLab工作流介绍-v4-含功能优化.pptx
+++ b/presentations/MiniseLab工作流介绍-v4-含功能优化.pptx
@@ -3087,6 +3087,14 @@
 <file path=ppt/slides/slide1.xml><?xml version="1.0" encoding="utf-8"?>
 <p:sld xmlns:a="http://schemas.openxmlformats.org/drawingml/2006/main" xmlns:p="http://schemas.openxmlformats.org/presentationml/2006/main" xmlns:r="http://schemas.openxmlformats.org/officeDocument/2006/relationships">
   <p:cSld>
+    <p:bg>
+      <p:bgPr>
+        <a:solidFill>
+          <a:srgbClr val="F6F7FB"/>
+        </a:solidFill>
+        <a:effectLst/>
+      </p:bgPr>
+    </p:bg>
     <p:spTree>
       <p:nvGrpSpPr>
         <p:cNvPr id="1" name=""/>
@@ -3094,30 +3102,362 @@
         <p:nvPr/>
       </p:nvGrpSpPr>
       <p:grpSpPr/>
-      <p:pic>
-        <p:nvPicPr>
-          <p:cNvPr id="2" name="Picture 1" descr="image.png"/>
-          <p:cNvPicPr>
-            <a:picLocks noChangeAspect="1"/>
-          </p:cNvPicPr>
+      <p:sp>
+        <p:nvSpPr>
+          <p:cNvPr id="2" name="Rectangle 1"/>
+          <p:cNvSpPr/>
           <p:nvPr/>
-        </p:nvPicPr>
-        <p:blipFill>
-          <a:blip r:embed="rId2"/>
-          <a:stretch>
-            <a:fillRect/>
-          </a:stretch>
-        </p:blipFill>
+        </p:nvSpPr>
         <p:spPr>
           <a:xfrm>
             <a:off x="0" y="0"/>
-            <a:ext cx="18288000" cy="10287000"/>
+            <a:ext cx="12191695" cy="502920"/>
           </a:xfrm>
           <a:prstGeom prst="rect">
             <a:avLst/>
           </a:prstGeom>
-        </p:spPr>
-      </p:pic>
+          <a:solidFill>
+            <a:srgbClr val="16213E"/>
+          </a:solidFill>
+          <a:ln>
+            <a:noFill/>
+          </a:ln>
+        </p:spPr>
+        <p:style>
+          <a:lnRef idx="1">
+            <a:schemeClr val="accent1"/>
+          </a:lnRef>
+          <a:fillRef idx="3">
+            <a:schemeClr val="accent1"/>
+          </a:fillRef>
+          <a:effectRef idx="2">
+            <a:schemeClr val="accent1"/>
+          </a:effectRef>
+          <a:fontRef idx="minor">
+            <a:schemeClr val="lt1"/>
+          </a:fontRef>
+        </p:style>
+        <p:txBody>
+          <a:bodyPr rtlCol="0" anchor="ctr"/>
+          <a:lstStyle/>
+          <a:p>
+            <a:pPr algn="ctr"/>
+          </a:p>
+        </p:txBody>
+      </p:sp>
+      <p:sp>
+        <p:nvSpPr>
+          <p:cNvPr id="3" name="TextBox 2"/>
+          <p:cNvSpPr txBox="1"/>
+          <p:nvPr/>
+        </p:nvSpPr>
+        <p:spPr>
+          <a:xfrm>
+            <a:off x="685800" y="822960"/>
+            <a:ext cx="9875520" cy="731520"/>
+          </a:xfrm>
+          <a:prstGeom prst="rect">
+            <a:avLst/>
+          </a:prstGeom>
+          <a:noFill/>
+        </p:spPr>
+        <p:txBody>
+          <a:bodyPr wrap="none">
+            <a:spAutoFit/>
+          </a:bodyPr>
+          <a:lstStyle/>
+          <a:p>
+            <a:r>
+              <a:rPr sz="2600" b="1">
+                <a:solidFill>
+                  <a:srgbClr val="16213E"/>
+                </a:solidFill>
+                <a:latin typeface="Microsoft YaHei"/>
+              </a:rPr>
+              <a:t>MiniseLab 工作流介绍</a:t>
+            </a:r>
+          </a:p>
+        </p:txBody>
+      </p:sp>
+      <p:sp>
+        <p:nvSpPr>
+          <p:cNvPr id="4" name="Rectangle 3"/>
+          <p:cNvSpPr/>
+          <p:nvPr/>
+        </p:nvSpPr>
+        <p:spPr>
+          <a:xfrm>
+            <a:off x="10012680" y="841248"/>
+            <a:ext cx="1463040" cy="384048"/>
+          </a:xfrm>
+          <a:prstGeom prst="rect">
+            <a:avLst/>
+          </a:prstGeom>
+          <a:solidFill>
+            <a:srgbClr val="2476FF"/>
+          </a:solidFill>
+          <a:ln>
+            <a:noFill/>
+          </a:ln>
+        </p:spPr>
+        <p:style>
+          <a:lnRef idx="1">
+            <a:schemeClr val="accent1"/>
+          </a:lnRef>
+          <a:fillRef idx="3">
+            <a:schemeClr val="accent1"/>
+          </a:fillRef>
+          <a:effectRef idx="2">
+            <a:schemeClr val="accent1"/>
+          </a:effectRef>
+          <a:fontRef idx="minor">
+            <a:schemeClr val="lt1"/>
+          </a:fontRef>
+        </p:style>
+        <p:txBody>
+          <a:bodyPr rtlCol="0" anchor="ctr"/>
+          <a:lstStyle/>
+          <a:p>
+            <a:pPr algn="ctr"/>
+            <a:r>
+              <a:rPr sz="1300" b="1">
+                <a:solidFill>
+                  <a:srgbClr val="FFFFFF"/>
+                </a:solidFill>
+                <a:latin typeface="Microsoft YaHei"/>
+              </a:rPr>
+              <a:t>第 1 页</a:t>
+            </a:r>
+          </a:p>
+        </p:txBody>
+      </p:sp>
+      <p:sp>
+        <p:nvSpPr>
+          <p:cNvPr id="5" name="TextBox 4"/>
+          <p:cNvSpPr txBox="1"/>
+          <p:nvPr/>
+        </p:nvSpPr>
+        <p:spPr>
+          <a:xfrm>
+            <a:off x="713232" y="1508760"/>
+            <a:ext cx="10698480" cy="502920"/>
+          </a:xfrm>
+          <a:prstGeom prst="rect">
+            <a:avLst/>
+          </a:prstGeom>
+          <a:noFill/>
+        </p:spPr>
+        <p:txBody>
+          <a:bodyPr wrap="none">
+            <a:spAutoFit/>
+          </a:bodyPr>
+          <a:lstStyle/>
+          <a:p>
+            <a:r>
+              <a:rPr sz="1400">
+                <a:solidFill>
+                  <a:srgbClr val="687282"/>
+                </a:solidFill>
+                <a:latin typeface="Microsoft YaHei"/>
+              </a:rPr>
+              <a:t>围绕 Stitch skill 的职责、顺序、交付物，把 MiniseLab 的设计协作流程讲清楚。</a:t>
+            </a:r>
+          </a:p>
+        </p:txBody>
+      </p:sp>
+      <p:sp>
+        <p:nvSpPr>
+          <p:cNvPr id="6" name="Rectangle 5"/>
+          <p:cNvSpPr/>
+          <p:nvPr/>
+        </p:nvSpPr>
+        <p:spPr>
+          <a:xfrm>
+            <a:off x="658368" y="1920240"/>
+            <a:ext cx="10881360" cy="5074920"/>
+          </a:xfrm>
+          <a:prstGeom prst="rect">
+            <a:avLst/>
+          </a:prstGeom>
+          <a:solidFill>
+            <a:srgbClr val="FFFFFF"/>
+          </a:solidFill>
+          <a:ln w="12700">
+            <a:solidFill>
+              <a:srgbClr val="DDE2EE"/>
+            </a:solidFill>
+          </a:ln>
+        </p:spPr>
+        <p:style>
+          <a:lnRef idx="1">
+            <a:schemeClr val="accent1"/>
+          </a:lnRef>
+          <a:fillRef idx="3">
+            <a:schemeClr val="accent1"/>
+          </a:fillRef>
+          <a:effectRef idx="2">
+            <a:schemeClr val="accent1"/>
+          </a:effectRef>
+          <a:fontRef idx="minor">
+            <a:schemeClr val="lt1"/>
+          </a:fontRef>
+        </p:style>
+        <p:txBody>
+          <a:bodyPr rtlCol="0" anchor="ctr"/>
+          <a:lstStyle/>
+          <a:p>
+            <a:pPr algn="ctr"/>
+          </a:p>
+        </p:txBody>
+      </p:sp>
+      <p:sp>
+        <p:nvSpPr>
+          <p:cNvPr id="7" name="Rectangle 6"/>
+          <p:cNvSpPr/>
+          <p:nvPr/>
+        </p:nvSpPr>
+        <p:spPr>
+          <a:xfrm>
+            <a:off x="822960" y="2148840"/>
+            <a:ext cx="109728" cy="4526280"/>
+          </a:xfrm>
+          <a:prstGeom prst="rect">
+            <a:avLst/>
+          </a:prstGeom>
+          <a:solidFill>
+            <a:srgbClr val="2476FF"/>
+          </a:solidFill>
+          <a:ln>
+            <a:noFill/>
+          </a:ln>
+        </p:spPr>
+        <p:style>
+          <a:lnRef idx="1">
+            <a:schemeClr val="accent1"/>
+          </a:lnRef>
+          <a:fillRef idx="3">
+            <a:schemeClr val="accent1"/>
+          </a:fillRef>
+          <a:effectRef idx="2">
+            <a:schemeClr val="accent1"/>
+          </a:effectRef>
+          <a:fontRef idx="minor">
+            <a:schemeClr val="lt1"/>
+          </a:fontRef>
+        </p:style>
+        <p:txBody>
+          <a:bodyPr rtlCol="0" anchor="ctr"/>
+          <a:lstStyle/>
+          <a:p>
+            <a:pPr algn="ctr"/>
+          </a:p>
+        </p:txBody>
+      </p:sp>
+      <p:sp>
+        <p:nvSpPr>
+          <p:cNvPr id="8" name="TextBox 7"/>
+          <p:cNvSpPr txBox="1"/>
+          <p:nvPr/>
+        </p:nvSpPr>
+        <p:spPr>
+          <a:xfrm>
+            <a:off x="1078992" y="2148840"/>
+            <a:ext cx="9966960" cy="4434840"/>
+          </a:xfrm>
+          <a:prstGeom prst="rect">
+            <a:avLst/>
+          </a:prstGeom>
+          <a:noFill/>
+        </p:spPr>
+        <p:txBody>
+          <a:bodyPr wrap="square">
+            <a:spAutoFit/>
+          </a:bodyPr>
+          <a:lstStyle/>
+          <a:p>
+            <a:pPr>
+              <a:spcAft>
+                <a:spcPts val="1400"/>
+              </a:spcAft>
+            </a:pPr>
+            <a:r>
+              <a:rPr sz="2400">
+                <a:solidFill>
+                  <a:srgbClr val="2C3440"/>
+                </a:solidFill>
+                <a:latin typeface="Microsoft YaHei"/>
+              </a:rPr>
+              <a:t>从需求到交付，围绕 Stitch 设计链路做标准化协作</a:t>
+            </a:r>
+          </a:p>
+          <a:p>
+            <a:pPr>
+              <a:spcAft>
+                <a:spcPts val="1400"/>
+              </a:spcAft>
+            </a:pPr>
+            <a:r>
+              <a:rPr sz="2400">
+                <a:solidFill>
+                  <a:srgbClr val="2C3440"/>
+                </a:solidFill>
+                <a:latin typeface="Microsoft YaHei"/>
+              </a:rPr>
+              <a:t>目标：让 Boss、设计阶段、工程阶段的分工更清晰</a:t>
+            </a:r>
+          </a:p>
+          <a:p>
+            <a:pPr>
+              <a:spcAft>
+                <a:spcPts val="1400"/>
+              </a:spcAft>
+            </a:pPr>
+            <a:r>
+              <a:rPr sz="2400">
+                <a:solidFill>
+                  <a:srgbClr val="2C3440"/>
+                </a:solidFill>
+                <a:latin typeface="Microsoft YaHei"/>
+              </a:rPr>
+              <a:t>重点升级：把 Stitch 相关 skill 的职责、顺序、交付物讲透</a:t>
+            </a:r>
+          </a:p>
+        </p:txBody>
+      </p:sp>
+      <p:sp>
+        <p:nvSpPr>
+          <p:cNvPr id="9" name="TextBox 8"/>
+          <p:cNvSpPr txBox="1"/>
+          <p:nvPr/>
+        </p:nvSpPr>
+        <p:spPr>
+          <a:xfrm>
+            <a:off x="713232" y="7223760"/>
+            <a:ext cx="10698480" cy="365760"/>
+          </a:xfrm>
+          <a:prstGeom prst="rect">
+            <a:avLst/>
+          </a:prstGeom>
+          <a:noFill/>
+        </p:spPr>
+        <p:txBody>
+          <a:bodyPr wrap="none">
+            <a:spAutoFit/>
+          </a:bodyPr>
+          <a:lstStyle/>
+          <a:p>
+            <a:r>
+              <a:rPr sz="1200" i="1">
+                <a:solidFill>
+                  <a:srgbClr val="2476FF"/>
+                </a:solidFill>
+                <a:latin typeface="Microsoft YaHei"/>
+              </a:rPr>
+              <a:t>v4 · Stitch skill 说明增强版</a:t>
+            </a:r>
+          </a:p>
+        </p:txBody>
+      </p:sp>
     </p:spTree>
   </p:cSld>
   <p:clrMapOvr>
@@ -3129,6 +3469,14 @@
 <file path=ppt/slides/slide2.xml><?xml version="1.0" encoding="utf-8"?>
 <p:sld xmlns:a="http://schemas.openxmlformats.org/drawingml/2006/main" xmlns:p="http://schemas.openxmlformats.org/presentationml/2006/main" xmlns:r="http://schemas.openxmlformats.org/officeDocument/2006/relationships">
   <p:cSld>
+    <p:bg>
+      <p:bgPr>
+        <a:solidFill>
+          <a:srgbClr val="F6F7FB"/>
+        </a:solidFill>
+        <a:effectLst/>
+      </p:bgPr>
+    </p:bg>
     <p:spTree>
       <p:nvGrpSpPr>
         <p:cNvPr id="1" name=""/>
@@ -3136,30 +3484,362 @@
         <p:nvPr/>
       </p:nvGrpSpPr>
       <p:grpSpPr/>
-      <p:pic>
-        <p:nvPicPr>
-          <p:cNvPr id="2" name="Picture 1" descr="image.png"/>
-          <p:cNvPicPr>
-            <a:picLocks noChangeAspect="1"/>
-          </p:cNvPicPr>
+      <p:sp>
+        <p:nvSpPr>
+          <p:cNvPr id="2" name="Rectangle 1"/>
+          <p:cNvSpPr/>
           <p:nvPr/>
-        </p:nvPicPr>
-        <p:blipFill>
-          <a:blip r:embed="rId2"/>
-          <a:stretch>
-            <a:fillRect/>
-          </a:stretch>
-        </p:blipFill>
+        </p:nvSpPr>
         <p:spPr>
           <a:xfrm>
             <a:off x="0" y="0"/>
-            <a:ext cx="18288000" cy="10287000"/>
+            <a:ext cx="12191695" cy="502920"/>
           </a:xfrm>
           <a:prstGeom prst="rect">
             <a:avLst/>
           </a:prstGeom>
-        </p:spPr>
-      </p:pic>
+          <a:solidFill>
+            <a:srgbClr val="16213E"/>
+          </a:solidFill>
+          <a:ln>
+            <a:noFill/>
+          </a:ln>
+        </p:spPr>
+        <p:style>
+          <a:lnRef idx="1">
+            <a:schemeClr val="accent1"/>
+          </a:lnRef>
+          <a:fillRef idx="3">
+            <a:schemeClr val="accent1"/>
+          </a:fillRef>
+          <a:effectRef idx="2">
+            <a:schemeClr val="accent1"/>
+          </a:effectRef>
+          <a:fontRef idx="minor">
+            <a:schemeClr val="lt1"/>
+          </a:fontRef>
+        </p:style>
+        <p:txBody>
+          <a:bodyPr rtlCol="0" anchor="ctr"/>
+          <a:lstStyle/>
+          <a:p>
+            <a:pPr algn="ctr"/>
+          </a:p>
+        </p:txBody>
+      </p:sp>
+      <p:sp>
+        <p:nvSpPr>
+          <p:cNvPr id="3" name="TextBox 2"/>
+          <p:cNvSpPr txBox="1"/>
+          <p:nvPr/>
+        </p:nvSpPr>
+        <p:spPr>
+          <a:xfrm>
+            <a:off x="685800" y="822960"/>
+            <a:ext cx="9875520" cy="731520"/>
+          </a:xfrm>
+          <a:prstGeom prst="rect">
+            <a:avLst/>
+          </a:prstGeom>
+          <a:noFill/>
+        </p:spPr>
+        <p:txBody>
+          <a:bodyPr wrap="none">
+            <a:spAutoFit/>
+          </a:bodyPr>
+          <a:lstStyle/>
+          <a:p>
+            <a:r>
+              <a:rPr sz="2600" b="1">
+                <a:solidFill>
+                  <a:srgbClr val="16213E"/>
+                </a:solidFill>
+                <a:latin typeface="Microsoft YaHei"/>
+              </a:rPr>
+              <a:t>为什么重点讲 Stitch</a:t>
+            </a:r>
+          </a:p>
+        </p:txBody>
+      </p:sp>
+      <p:sp>
+        <p:nvSpPr>
+          <p:cNvPr id="4" name="Rectangle 3"/>
+          <p:cNvSpPr/>
+          <p:nvPr/>
+        </p:nvSpPr>
+        <p:spPr>
+          <a:xfrm>
+            <a:off x="10012680" y="841248"/>
+            <a:ext cx="1463040" cy="384048"/>
+          </a:xfrm>
+          <a:prstGeom prst="rect">
+            <a:avLst/>
+          </a:prstGeom>
+          <a:solidFill>
+            <a:srgbClr val="2476FF"/>
+          </a:solidFill>
+          <a:ln>
+            <a:noFill/>
+          </a:ln>
+        </p:spPr>
+        <p:style>
+          <a:lnRef idx="1">
+            <a:schemeClr val="accent1"/>
+          </a:lnRef>
+          <a:fillRef idx="3">
+            <a:schemeClr val="accent1"/>
+          </a:fillRef>
+          <a:effectRef idx="2">
+            <a:schemeClr val="accent1"/>
+          </a:effectRef>
+          <a:fontRef idx="minor">
+            <a:schemeClr val="lt1"/>
+          </a:fontRef>
+        </p:style>
+        <p:txBody>
+          <a:bodyPr rtlCol="0" anchor="ctr"/>
+          <a:lstStyle/>
+          <a:p>
+            <a:pPr algn="ctr"/>
+            <a:r>
+              <a:rPr sz="1300" b="1">
+                <a:solidFill>
+                  <a:srgbClr val="FFFFFF"/>
+                </a:solidFill>
+                <a:latin typeface="Microsoft YaHei"/>
+              </a:rPr>
+              <a:t>第 2 页</a:t>
+            </a:r>
+          </a:p>
+        </p:txBody>
+      </p:sp>
+      <p:sp>
+        <p:nvSpPr>
+          <p:cNvPr id="5" name="TextBox 4"/>
+          <p:cNvSpPr txBox="1"/>
+          <p:nvPr/>
+        </p:nvSpPr>
+        <p:spPr>
+          <a:xfrm>
+            <a:off x="713232" y="1508760"/>
+            <a:ext cx="10698480" cy="502920"/>
+          </a:xfrm>
+          <a:prstGeom prst="rect">
+            <a:avLst/>
+          </a:prstGeom>
+          <a:noFill/>
+        </p:spPr>
+        <p:txBody>
+          <a:bodyPr wrap="none">
+            <a:spAutoFit/>
+          </a:bodyPr>
+          <a:lstStyle/>
+          <a:p>
+            <a:r>
+              <a:rPr sz="1400">
+                <a:solidFill>
+                  <a:srgbClr val="687282"/>
+                </a:solidFill>
+                <a:latin typeface="Microsoft YaHei"/>
+              </a:rPr>
+              <a:t>围绕 Stitch skill 的职责、顺序、交付物，把 MiniseLab 的设计协作流程讲清楚。</a:t>
+            </a:r>
+          </a:p>
+        </p:txBody>
+      </p:sp>
+      <p:sp>
+        <p:nvSpPr>
+          <p:cNvPr id="6" name="Rectangle 5"/>
+          <p:cNvSpPr/>
+          <p:nvPr/>
+        </p:nvSpPr>
+        <p:spPr>
+          <a:xfrm>
+            <a:off x="658368" y="1920240"/>
+            <a:ext cx="10881360" cy="5074920"/>
+          </a:xfrm>
+          <a:prstGeom prst="rect">
+            <a:avLst/>
+          </a:prstGeom>
+          <a:solidFill>
+            <a:srgbClr val="FFFFFF"/>
+          </a:solidFill>
+          <a:ln w="12700">
+            <a:solidFill>
+              <a:srgbClr val="DDE2EE"/>
+            </a:solidFill>
+          </a:ln>
+        </p:spPr>
+        <p:style>
+          <a:lnRef idx="1">
+            <a:schemeClr val="accent1"/>
+          </a:lnRef>
+          <a:fillRef idx="3">
+            <a:schemeClr val="accent1"/>
+          </a:fillRef>
+          <a:effectRef idx="2">
+            <a:schemeClr val="accent1"/>
+          </a:effectRef>
+          <a:fontRef idx="minor">
+            <a:schemeClr val="lt1"/>
+          </a:fontRef>
+        </p:style>
+        <p:txBody>
+          <a:bodyPr rtlCol="0" anchor="ctr"/>
+          <a:lstStyle/>
+          <a:p>
+            <a:pPr algn="ctr"/>
+          </a:p>
+        </p:txBody>
+      </p:sp>
+      <p:sp>
+        <p:nvSpPr>
+          <p:cNvPr id="7" name="Rectangle 6"/>
+          <p:cNvSpPr/>
+          <p:nvPr/>
+        </p:nvSpPr>
+        <p:spPr>
+          <a:xfrm>
+            <a:off x="822960" y="2148840"/>
+            <a:ext cx="109728" cy="4526280"/>
+          </a:xfrm>
+          <a:prstGeom prst="rect">
+            <a:avLst/>
+          </a:prstGeom>
+          <a:solidFill>
+            <a:srgbClr val="2476FF"/>
+          </a:solidFill>
+          <a:ln>
+            <a:noFill/>
+          </a:ln>
+        </p:spPr>
+        <p:style>
+          <a:lnRef idx="1">
+            <a:schemeClr val="accent1"/>
+          </a:lnRef>
+          <a:fillRef idx="3">
+            <a:schemeClr val="accent1"/>
+          </a:fillRef>
+          <a:effectRef idx="2">
+            <a:schemeClr val="accent1"/>
+          </a:effectRef>
+          <a:fontRef idx="minor">
+            <a:schemeClr val="lt1"/>
+          </a:fontRef>
+        </p:style>
+        <p:txBody>
+          <a:bodyPr rtlCol="0" anchor="ctr"/>
+          <a:lstStyle/>
+          <a:p>
+            <a:pPr algn="ctr"/>
+          </a:p>
+        </p:txBody>
+      </p:sp>
+      <p:sp>
+        <p:nvSpPr>
+          <p:cNvPr id="8" name="TextBox 7"/>
+          <p:cNvSpPr txBox="1"/>
+          <p:nvPr/>
+        </p:nvSpPr>
+        <p:spPr>
+          <a:xfrm>
+            <a:off x="1078992" y="2148840"/>
+            <a:ext cx="9966960" cy="4434840"/>
+          </a:xfrm>
+          <a:prstGeom prst="rect">
+            <a:avLst/>
+          </a:prstGeom>
+          <a:noFill/>
+        </p:spPr>
+        <p:txBody>
+          <a:bodyPr wrap="square">
+            <a:spAutoFit/>
+          </a:bodyPr>
+          <a:lstStyle/>
+          <a:p>
+            <a:pPr>
+              <a:spcAft>
+                <a:spcPts val="1400"/>
+              </a:spcAft>
+            </a:pPr>
+            <a:r>
+              <a:rPr sz="2400">
+                <a:solidFill>
+                  <a:srgbClr val="2C3440"/>
+                </a:solidFill>
+                <a:latin typeface="Microsoft YaHei"/>
+              </a:rPr>
+              <a:t>Stitch 不是单个工具，而是一条 UI 产出流水线的起点</a:t>
+            </a:r>
+          </a:p>
+          <a:p>
+            <a:pPr>
+              <a:spcAft>
+                <a:spcPts val="1400"/>
+              </a:spcAft>
+            </a:pPr>
+            <a:r>
+              <a:rPr sz="2400">
+                <a:solidFill>
+                  <a:srgbClr val="2C3440"/>
+                </a:solidFill>
+                <a:latin typeface="Microsoft YaHei"/>
+              </a:rPr>
+              <a:t>它负责把 Boss 的模糊想法，快速变成可截图、可确认、可下载 HTML 的设计稿</a:t>
+            </a:r>
+          </a:p>
+          <a:p>
+            <a:pPr>
+              <a:spcAft>
+                <a:spcPts val="1400"/>
+              </a:spcAft>
+            </a:pPr>
+            <a:r>
+              <a:rPr sz="2400">
+                <a:solidFill>
+                  <a:srgbClr val="2C3440"/>
+                </a:solidFill>
+                <a:latin typeface="Microsoft YaHei"/>
+              </a:rPr>
+              <a:t>后续前端工程化是否顺畅，取决于前面这套 skill 是否配合正确</a:t>
+            </a:r>
+          </a:p>
+        </p:txBody>
+      </p:sp>
+      <p:sp>
+        <p:nvSpPr>
+          <p:cNvPr id="9" name="TextBox 8"/>
+          <p:cNvSpPr txBox="1"/>
+          <p:nvPr/>
+        </p:nvSpPr>
+        <p:spPr>
+          <a:xfrm>
+            <a:off x="713232" y="7223760"/>
+            <a:ext cx="10698480" cy="365760"/>
+          </a:xfrm>
+          <a:prstGeom prst="rect">
+            <a:avLst/>
+          </a:prstGeom>
+          <a:noFill/>
+        </p:spPr>
+        <p:txBody>
+          <a:bodyPr wrap="none">
+            <a:spAutoFit/>
+          </a:bodyPr>
+          <a:lstStyle/>
+          <a:p>
+            <a:r>
+              <a:rPr sz="1200" i="1">
+                <a:solidFill>
+                  <a:srgbClr val="2476FF"/>
+                </a:solidFill>
+                <a:latin typeface="Microsoft YaHei"/>
+              </a:rPr>
+              <a:t>核心价值：先把设计真相固定下来，再谈还原</a:t>
+            </a:r>
+          </a:p>
+        </p:txBody>
+      </p:sp>
     </p:spTree>
   </p:cSld>
   <p:clrMapOvr>
@@ -3171,6 +3851,14 @@
 <file path=ppt/slides/slide3.xml><?xml version="1.0" encoding="utf-8"?>
 <p:sld xmlns:a="http://schemas.openxmlformats.org/drawingml/2006/main" xmlns:p="http://schemas.openxmlformats.org/presentationml/2006/main" xmlns:r="http://schemas.openxmlformats.org/officeDocument/2006/relationships">
   <p:cSld>
+    <p:bg>
+      <p:bgPr>
+        <a:solidFill>
+          <a:srgbClr val="F6F7FB"/>
+        </a:solidFill>
+        <a:effectLst/>
+      </p:bgPr>
+    </p:bg>
     <p:spTree>
       <p:nvGrpSpPr>
         <p:cNvPr id="1" name=""/>
@@ -3178,30 +3866,362 @@
         <p:nvPr/>
       </p:nvGrpSpPr>
       <p:grpSpPr/>
-      <p:pic>
-        <p:nvPicPr>
-          <p:cNvPr id="2" name="Picture 1" descr="image.png"/>
-          <p:cNvPicPr>
-            <a:picLocks noChangeAspect="1"/>
-          </p:cNvPicPr>
+      <p:sp>
+        <p:nvSpPr>
+          <p:cNvPr id="2" name="Rectangle 1"/>
+          <p:cNvSpPr/>
           <p:nvPr/>
-        </p:nvPicPr>
-        <p:blipFill>
-          <a:blip r:embed="rId2"/>
-          <a:stretch>
-            <a:fillRect/>
-          </a:stretch>
-        </p:blipFill>
+        </p:nvSpPr>
         <p:spPr>
           <a:xfrm>
             <a:off x="0" y="0"/>
-            <a:ext cx="18288000" cy="10287000"/>
+            <a:ext cx="12191695" cy="502920"/>
           </a:xfrm>
           <a:prstGeom prst="rect">
             <a:avLst/>
           </a:prstGeom>
-        </p:spPr>
-      </p:pic>
+          <a:solidFill>
+            <a:srgbClr val="16213E"/>
+          </a:solidFill>
+          <a:ln>
+            <a:noFill/>
+          </a:ln>
+        </p:spPr>
+        <p:style>
+          <a:lnRef idx="1">
+            <a:schemeClr val="accent1"/>
+          </a:lnRef>
+          <a:fillRef idx="3">
+            <a:schemeClr val="accent1"/>
+          </a:fillRef>
+          <a:effectRef idx="2">
+            <a:schemeClr val="accent1"/>
+          </a:effectRef>
+          <a:fontRef idx="minor">
+            <a:schemeClr val="lt1"/>
+          </a:fontRef>
+        </p:style>
+        <p:txBody>
+          <a:bodyPr rtlCol="0" anchor="ctr"/>
+          <a:lstStyle/>
+          <a:p>
+            <a:pPr algn="ctr"/>
+          </a:p>
+        </p:txBody>
+      </p:sp>
+      <p:sp>
+        <p:nvSpPr>
+          <p:cNvPr id="3" name="TextBox 2"/>
+          <p:cNvSpPr txBox="1"/>
+          <p:nvPr/>
+        </p:nvSpPr>
+        <p:spPr>
+          <a:xfrm>
+            <a:off x="685800" y="822960"/>
+            <a:ext cx="9875520" cy="731520"/>
+          </a:xfrm>
+          <a:prstGeom prst="rect">
+            <a:avLst/>
+          </a:prstGeom>
+          <a:noFill/>
+        </p:spPr>
+        <p:txBody>
+          <a:bodyPr wrap="none">
+            <a:spAutoFit/>
+          </a:bodyPr>
+          <a:lstStyle/>
+          <a:p>
+            <a:r>
+              <a:rPr sz="2600" b="1">
+                <a:solidFill>
+                  <a:srgbClr val="16213E"/>
+                </a:solidFill>
+                <a:latin typeface="Microsoft YaHei"/>
+              </a:rPr>
+              <a:t>Stitch 设计阶段必用 Skill</a:t>
+            </a:r>
+          </a:p>
+        </p:txBody>
+      </p:sp>
+      <p:sp>
+        <p:nvSpPr>
+          <p:cNvPr id="4" name="Rectangle 3"/>
+          <p:cNvSpPr/>
+          <p:nvPr/>
+        </p:nvSpPr>
+        <p:spPr>
+          <a:xfrm>
+            <a:off x="10012680" y="841248"/>
+            <a:ext cx="1463040" cy="384048"/>
+          </a:xfrm>
+          <a:prstGeom prst="rect">
+            <a:avLst/>
+          </a:prstGeom>
+          <a:solidFill>
+            <a:srgbClr val="2476FF"/>
+          </a:solidFill>
+          <a:ln>
+            <a:noFill/>
+          </a:ln>
+        </p:spPr>
+        <p:style>
+          <a:lnRef idx="1">
+            <a:schemeClr val="accent1"/>
+          </a:lnRef>
+          <a:fillRef idx="3">
+            <a:schemeClr val="accent1"/>
+          </a:fillRef>
+          <a:effectRef idx="2">
+            <a:schemeClr val="accent1"/>
+          </a:effectRef>
+          <a:fontRef idx="minor">
+            <a:schemeClr val="lt1"/>
+          </a:fontRef>
+        </p:style>
+        <p:txBody>
+          <a:bodyPr rtlCol="0" anchor="ctr"/>
+          <a:lstStyle/>
+          <a:p>
+            <a:pPr algn="ctr"/>
+            <a:r>
+              <a:rPr sz="1300" b="1">
+                <a:solidFill>
+                  <a:srgbClr val="FFFFFF"/>
+                </a:solidFill>
+                <a:latin typeface="Microsoft YaHei"/>
+              </a:rPr>
+              <a:t>第 3 页</a:t>
+            </a:r>
+          </a:p>
+        </p:txBody>
+      </p:sp>
+      <p:sp>
+        <p:nvSpPr>
+          <p:cNvPr id="5" name="TextBox 4"/>
+          <p:cNvSpPr txBox="1"/>
+          <p:nvPr/>
+        </p:nvSpPr>
+        <p:spPr>
+          <a:xfrm>
+            <a:off x="713232" y="1508760"/>
+            <a:ext cx="10698480" cy="502920"/>
+          </a:xfrm>
+          <a:prstGeom prst="rect">
+            <a:avLst/>
+          </a:prstGeom>
+          <a:noFill/>
+        </p:spPr>
+        <p:txBody>
+          <a:bodyPr wrap="none">
+            <a:spAutoFit/>
+          </a:bodyPr>
+          <a:lstStyle/>
+          <a:p>
+            <a:r>
+              <a:rPr sz="1400">
+                <a:solidFill>
+                  <a:srgbClr val="687282"/>
+                </a:solidFill>
+                <a:latin typeface="Microsoft YaHei"/>
+              </a:rPr>
+              <a:t>围绕 Stitch skill 的职责、顺序、交付物，把 MiniseLab 的设计协作流程讲清楚。</a:t>
+            </a:r>
+          </a:p>
+        </p:txBody>
+      </p:sp>
+      <p:sp>
+        <p:nvSpPr>
+          <p:cNvPr id="6" name="Rectangle 5"/>
+          <p:cNvSpPr/>
+          <p:nvPr/>
+        </p:nvSpPr>
+        <p:spPr>
+          <a:xfrm>
+            <a:off x="658368" y="1920240"/>
+            <a:ext cx="10881360" cy="5074920"/>
+          </a:xfrm>
+          <a:prstGeom prst="rect">
+            <a:avLst/>
+          </a:prstGeom>
+          <a:solidFill>
+            <a:srgbClr val="FFFFFF"/>
+          </a:solidFill>
+          <a:ln w="12700">
+            <a:solidFill>
+              <a:srgbClr val="DDE2EE"/>
+            </a:solidFill>
+          </a:ln>
+        </p:spPr>
+        <p:style>
+          <a:lnRef idx="1">
+            <a:schemeClr val="accent1"/>
+          </a:lnRef>
+          <a:fillRef idx="3">
+            <a:schemeClr val="accent1"/>
+          </a:fillRef>
+          <a:effectRef idx="2">
+            <a:schemeClr val="accent1"/>
+          </a:effectRef>
+          <a:fontRef idx="minor">
+            <a:schemeClr val="lt1"/>
+          </a:fontRef>
+        </p:style>
+        <p:txBody>
+          <a:bodyPr rtlCol="0" anchor="ctr"/>
+          <a:lstStyle/>
+          <a:p>
+            <a:pPr algn="ctr"/>
+          </a:p>
+        </p:txBody>
+      </p:sp>
+      <p:sp>
+        <p:nvSpPr>
+          <p:cNvPr id="7" name="Rectangle 6"/>
+          <p:cNvSpPr/>
+          <p:nvPr/>
+        </p:nvSpPr>
+        <p:spPr>
+          <a:xfrm>
+            <a:off x="822960" y="2148840"/>
+            <a:ext cx="109728" cy="4526280"/>
+          </a:xfrm>
+          <a:prstGeom prst="rect">
+            <a:avLst/>
+          </a:prstGeom>
+          <a:solidFill>
+            <a:srgbClr val="2476FF"/>
+          </a:solidFill>
+          <a:ln>
+            <a:noFill/>
+          </a:ln>
+        </p:spPr>
+        <p:style>
+          <a:lnRef idx="1">
+            <a:schemeClr val="accent1"/>
+          </a:lnRef>
+          <a:fillRef idx="3">
+            <a:schemeClr val="accent1"/>
+          </a:fillRef>
+          <a:effectRef idx="2">
+            <a:schemeClr val="accent1"/>
+          </a:effectRef>
+          <a:fontRef idx="minor">
+            <a:schemeClr val="lt1"/>
+          </a:fontRef>
+        </p:style>
+        <p:txBody>
+          <a:bodyPr rtlCol="0" anchor="ctr"/>
+          <a:lstStyle/>
+          <a:p>
+            <a:pPr algn="ctr"/>
+          </a:p>
+        </p:txBody>
+      </p:sp>
+      <p:sp>
+        <p:nvSpPr>
+          <p:cNvPr id="8" name="TextBox 7"/>
+          <p:cNvSpPr txBox="1"/>
+          <p:nvPr/>
+        </p:nvSpPr>
+        <p:spPr>
+          <a:xfrm>
+            <a:off x="1078992" y="2148840"/>
+            <a:ext cx="9966960" cy="4434840"/>
+          </a:xfrm>
+          <a:prstGeom prst="rect">
+            <a:avLst/>
+          </a:prstGeom>
+          <a:noFill/>
+        </p:spPr>
+        <p:txBody>
+          <a:bodyPr wrap="square">
+            <a:spAutoFit/>
+          </a:bodyPr>
+          <a:lstStyle/>
+          <a:p>
+            <a:pPr>
+              <a:spcAft>
+                <a:spcPts val="1400"/>
+              </a:spcAft>
+            </a:pPr>
+            <a:r>
+              <a:rPr sz="2400">
+                <a:solidFill>
+                  <a:srgbClr val="2C3440"/>
+                </a:solidFill>
+                <a:latin typeface="Microsoft YaHei"/>
+              </a:rPr>
+              <a:t>1. enhance-prompt：把原始需求补全成高质量 Stitch prompt，明确设备、风格、配色、页面结构，且强制所有文案使用中文</a:t>
+            </a:r>
+          </a:p>
+          <a:p>
+            <a:pPr>
+              <a:spcAft>
+                <a:spcPts val="1400"/>
+              </a:spcAft>
+            </a:pPr>
+            <a:r>
+              <a:rPr sz="2400">
+                <a:solidFill>
+                  <a:srgbClr val="2C3440"/>
+                </a:solidFill>
+                <a:latin typeface="Microsoft YaHei"/>
+              </a:rPr>
+              <a:t>2. stitch-designer：真正执行设计生成、截图、收集 Boss 反馈、迭代页面，是 Stitch 设计阶段的主控 skill</a:t>
+            </a:r>
+          </a:p>
+          <a:p>
+            <a:pPr>
+              <a:spcAft>
+                <a:spcPts val="1400"/>
+              </a:spcAft>
+            </a:pPr>
+            <a:r>
+              <a:rPr sz="2400">
+                <a:solidFill>
+                  <a:srgbClr val="2C3440"/>
+                </a:solidFill>
+                <a:latin typeface="Microsoft YaHei"/>
+              </a:rPr>
+              <a:t>3. design-md：在 Boss 确认设计稿后，提炼统一设计系统，沉淀 DESIGN.md，保证后续新增页面风格一致</a:t>
+            </a:r>
+          </a:p>
+        </p:txBody>
+      </p:sp>
+      <p:sp>
+        <p:nvSpPr>
+          <p:cNvPr id="9" name="TextBox 8"/>
+          <p:cNvSpPr txBox="1"/>
+          <p:nvPr/>
+        </p:nvSpPr>
+        <p:spPr>
+          <a:xfrm>
+            <a:off x="713232" y="7223760"/>
+            <a:ext cx="10698480" cy="365760"/>
+          </a:xfrm>
+          <a:prstGeom prst="rect">
+            <a:avLst/>
+          </a:prstGeom>
+          <a:noFill/>
+        </p:spPr>
+        <p:txBody>
+          <a:bodyPr wrap="none">
+            <a:spAutoFit/>
+          </a:bodyPr>
+          <a:lstStyle/>
+          <a:p>
+            <a:r>
+              <a:rPr sz="1200" i="1">
+                <a:solidFill>
+                  <a:srgbClr val="2476FF"/>
+                </a:solidFill>
+                <a:latin typeface="Microsoft YaHei"/>
+              </a:rPr>
+              <a:t>这三个是设计阶段的固定组合，不要跳步</a:t>
+            </a:r>
+          </a:p>
+        </p:txBody>
+      </p:sp>
     </p:spTree>
   </p:cSld>
   <p:clrMapOvr>
@@ -3213,6 +4233,14 @@
 <file path=ppt/slides/slide4.xml><?xml version="1.0" encoding="utf-8"?>
 <p:sld xmlns:a="http://schemas.openxmlformats.org/drawingml/2006/main" xmlns:p="http://schemas.openxmlformats.org/presentationml/2006/main" xmlns:r="http://schemas.openxmlformats.org/officeDocument/2006/relationships">
   <p:cSld>
+    <p:bg>
+      <p:bgPr>
+        <a:solidFill>
+          <a:srgbClr val="F6F7FB"/>
+        </a:solidFill>
+        <a:effectLst/>
+      </p:bgPr>
+    </p:bg>
     <p:spTree>
       <p:nvGrpSpPr>
         <p:cNvPr id="1" name=""/>
@@ -3220,30 +4248,410 @@
         <p:nvPr/>
       </p:nvGrpSpPr>
       <p:grpSpPr/>
-      <p:pic>
-        <p:nvPicPr>
-          <p:cNvPr id="2" name="Picture 1" descr="image.png"/>
-          <p:cNvPicPr>
-            <a:picLocks noChangeAspect="1"/>
-          </p:cNvPicPr>
+      <p:sp>
+        <p:nvSpPr>
+          <p:cNvPr id="2" name="Rectangle 1"/>
+          <p:cNvSpPr/>
           <p:nvPr/>
-        </p:nvPicPr>
-        <p:blipFill>
-          <a:blip r:embed="rId2"/>
-          <a:stretch>
-            <a:fillRect/>
-          </a:stretch>
-        </p:blipFill>
+        </p:nvSpPr>
         <p:spPr>
           <a:xfrm>
             <a:off x="0" y="0"/>
-            <a:ext cx="18288000" cy="10287000"/>
+            <a:ext cx="12191695" cy="502920"/>
           </a:xfrm>
           <a:prstGeom prst="rect">
             <a:avLst/>
           </a:prstGeom>
-        </p:spPr>
-      </p:pic>
+          <a:solidFill>
+            <a:srgbClr val="16213E"/>
+          </a:solidFill>
+          <a:ln>
+            <a:noFill/>
+          </a:ln>
+        </p:spPr>
+        <p:style>
+          <a:lnRef idx="1">
+            <a:schemeClr val="accent1"/>
+          </a:lnRef>
+          <a:fillRef idx="3">
+            <a:schemeClr val="accent1"/>
+          </a:fillRef>
+          <a:effectRef idx="2">
+            <a:schemeClr val="accent1"/>
+          </a:effectRef>
+          <a:fontRef idx="minor">
+            <a:schemeClr val="lt1"/>
+          </a:fontRef>
+        </p:style>
+        <p:txBody>
+          <a:bodyPr rtlCol="0" anchor="ctr"/>
+          <a:lstStyle/>
+          <a:p>
+            <a:pPr algn="ctr"/>
+          </a:p>
+        </p:txBody>
+      </p:sp>
+      <p:sp>
+        <p:nvSpPr>
+          <p:cNvPr id="3" name="TextBox 2"/>
+          <p:cNvSpPr txBox="1"/>
+          <p:nvPr/>
+        </p:nvSpPr>
+        <p:spPr>
+          <a:xfrm>
+            <a:off x="685800" y="822960"/>
+            <a:ext cx="9875520" cy="731520"/>
+          </a:xfrm>
+          <a:prstGeom prst="rect">
+            <a:avLst/>
+          </a:prstGeom>
+          <a:noFill/>
+        </p:spPr>
+        <p:txBody>
+          <a:bodyPr wrap="none">
+            <a:spAutoFit/>
+          </a:bodyPr>
+          <a:lstStyle/>
+          <a:p>
+            <a:r>
+              <a:rPr sz="2600" b="1">
+                <a:solidFill>
+                  <a:srgbClr val="16213E"/>
+                </a:solidFill>
+                <a:latin typeface="Microsoft YaHei"/>
+              </a:rPr>
+              <a:t>完整工作流：从需求到设计确认</a:t>
+            </a:r>
+          </a:p>
+        </p:txBody>
+      </p:sp>
+      <p:sp>
+        <p:nvSpPr>
+          <p:cNvPr id="4" name="Rectangle 3"/>
+          <p:cNvSpPr/>
+          <p:nvPr/>
+        </p:nvSpPr>
+        <p:spPr>
+          <a:xfrm>
+            <a:off x="10012680" y="841248"/>
+            <a:ext cx="1463040" cy="384048"/>
+          </a:xfrm>
+          <a:prstGeom prst="rect">
+            <a:avLst/>
+          </a:prstGeom>
+          <a:solidFill>
+            <a:srgbClr val="2476FF"/>
+          </a:solidFill>
+          <a:ln>
+            <a:noFill/>
+          </a:ln>
+        </p:spPr>
+        <p:style>
+          <a:lnRef idx="1">
+            <a:schemeClr val="accent1"/>
+          </a:lnRef>
+          <a:fillRef idx="3">
+            <a:schemeClr val="accent1"/>
+          </a:fillRef>
+          <a:effectRef idx="2">
+            <a:schemeClr val="accent1"/>
+          </a:effectRef>
+          <a:fontRef idx="minor">
+            <a:schemeClr val="lt1"/>
+          </a:fontRef>
+        </p:style>
+        <p:txBody>
+          <a:bodyPr rtlCol="0" anchor="ctr"/>
+          <a:lstStyle/>
+          <a:p>
+            <a:pPr algn="ctr"/>
+            <a:r>
+              <a:rPr sz="1300" b="1">
+                <a:solidFill>
+                  <a:srgbClr val="FFFFFF"/>
+                </a:solidFill>
+                <a:latin typeface="Microsoft YaHei"/>
+              </a:rPr>
+              <a:t>第 4 页</a:t>
+            </a:r>
+          </a:p>
+        </p:txBody>
+      </p:sp>
+      <p:sp>
+        <p:nvSpPr>
+          <p:cNvPr id="5" name="TextBox 4"/>
+          <p:cNvSpPr txBox="1"/>
+          <p:nvPr/>
+        </p:nvSpPr>
+        <p:spPr>
+          <a:xfrm>
+            <a:off x="713232" y="1508760"/>
+            <a:ext cx="10698480" cy="502920"/>
+          </a:xfrm>
+          <a:prstGeom prst="rect">
+            <a:avLst/>
+          </a:prstGeom>
+          <a:noFill/>
+        </p:spPr>
+        <p:txBody>
+          <a:bodyPr wrap="none">
+            <a:spAutoFit/>
+          </a:bodyPr>
+          <a:lstStyle/>
+          <a:p>
+            <a:r>
+              <a:rPr sz="1400">
+                <a:solidFill>
+                  <a:srgbClr val="687282"/>
+                </a:solidFill>
+                <a:latin typeface="Microsoft YaHei"/>
+              </a:rPr>
+              <a:t>围绕 Stitch skill 的职责、顺序、交付物，把 MiniseLab 的设计协作流程讲清楚。</a:t>
+            </a:r>
+          </a:p>
+        </p:txBody>
+      </p:sp>
+      <p:sp>
+        <p:nvSpPr>
+          <p:cNvPr id="6" name="Rectangle 5"/>
+          <p:cNvSpPr/>
+          <p:nvPr/>
+        </p:nvSpPr>
+        <p:spPr>
+          <a:xfrm>
+            <a:off x="658368" y="1920240"/>
+            <a:ext cx="10881360" cy="5074920"/>
+          </a:xfrm>
+          <a:prstGeom prst="rect">
+            <a:avLst/>
+          </a:prstGeom>
+          <a:solidFill>
+            <a:srgbClr val="FFFFFF"/>
+          </a:solidFill>
+          <a:ln w="12700">
+            <a:solidFill>
+              <a:srgbClr val="DDE2EE"/>
+            </a:solidFill>
+          </a:ln>
+        </p:spPr>
+        <p:style>
+          <a:lnRef idx="1">
+            <a:schemeClr val="accent1"/>
+          </a:lnRef>
+          <a:fillRef idx="3">
+            <a:schemeClr val="accent1"/>
+          </a:fillRef>
+          <a:effectRef idx="2">
+            <a:schemeClr val="accent1"/>
+          </a:effectRef>
+          <a:fontRef idx="minor">
+            <a:schemeClr val="lt1"/>
+          </a:fontRef>
+        </p:style>
+        <p:txBody>
+          <a:bodyPr rtlCol="0" anchor="ctr"/>
+          <a:lstStyle/>
+          <a:p>
+            <a:pPr algn="ctr"/>
+          </a:p>
+        </p:txBody>
+      </p:sp>
+      <p:sp>
+        <p:nvSpPr>
+          <p:cNvPr id="7" name="Rectangle 6"/>
+          <p:cNvSpPr/>
+          <p:nvPr/>
+        </p:nvSpPr>
+        <p:spPr>
+          <a:xfrm>
+            <a:off x="822960" y="2148840"/>
+            <a:ext cx="109728" cy="4526280"/>
+          </a:xfrm>
+          <a:prstGeom prst="rect">
+            <a:avLst/>
+          </a:prstGeom>
+          <a:solidFill>
+            <a:srgbClr val="2476FF"/>
+          </a:solidFill>
+          <a:ln>
+            <a:noFill/>
+          </a:ln>
+        </p:spPr>
+        <p:style>
+          <a:lnRef idx="1">
+            <a:schemeClr val="accent1"/>
+          </a:lnRef>
+          <a:fillRef idx="3">
+            <a:schemeClr val="accent1"/>
+          </a:fillRef>
+          <a:effectRef idx="2">
+            <a:schemeClr val="accent1"/>
+          </a:effectRef>
+          <a:fontRef idx="minor">
+            <a:schemeClr val="lt1"/>
+          </a:fontRef>
+        </p:style>
+        <p:txBody>
+          <a:bodyPr rtlCol="0" anchor="ctr"/>
+          <a:lstStyle/>
+          <a:p>
+            <a:pPr algn="ctr"/>
+          </a:p>
+        </p:txBody>
+      </p:sp>
+      <p:sp>
+        <p:nvSpPr>
+          <p:cNvPr id="8" name="TextBox 7"/>
+          <p:cNvSpPr txBox="1"/>
+          <p:nvPr/>
+        </p:nvSpPr>
+        <p:spPr>
+          <a:xfrm>
+            <a:off x="1078992" y="2148840"/>
+            <a:ext cx="9966960" cy="4434840"/>
+          </a:xfrm>
+          <a:prstGeom prst="rect">
+            <a:avLst/>
+          </a:prstGeom>
+          <a:noFill/>
+        </p:spPr>
+        <p:txBody>
+          <a:bodyPr wrap="square">
+            <a:spAutoFit/>
+          </a:bodyPr>
+          <a:lstStyle/>
+          <a:p>
+            <a:pPr>
+              <a:spcAft>
+                <a:spcPts val="1400"/>
+              </a:spcAft>
+            </a:pPr>
+            <a:r>
+              <a:rPr sz="2100">
+                <a:solidFill>
+                  <a:srgbClr val="2C3440"/>
+                </a:solidFill>
+                <a:latin typeface="Microsoft YaHei"/>
+              </a:rPr>
+              <a:t>Step 1｜Boss 提需求：先确认页面清单、设备类型、风格方向，不猜测不脑补</a:t>
+            </a:r>
+          </a:p>
+          <a:p>
+            <a:pPr>
+              <a:spcAft>
+                <a:spcPts val="1400"/>
+              </a:spcAft>
+            </a:pPr>
+            <a:r>
+              <a:rPr sz="2100">
+                <a:solidFill>
+                  <a:srgbClr val="2C3440"/>
+                </a:solidFill>
+                <a:latin typeface="Microsoft YaHei"/>
+              </a:rPr>
+              <a:t>Step 2｜enhance-prompt 优化：把一句话需求变成结构化 prompt，写清 Header / Hero / Content / Footer</a:t>
+            </a:r>
+          </a:p>
+          <a:p>
+            <a:pPr>
+              <a:spcAft>
+                <a:spcPts val="1400"/>
+              </a:spcAft>
+            </a:pPr>
+            <a:r>
+              <a:rPr sz="2100">
+                <a:solidFill>
+                  <a:srgbClr val="2C3440"/>
+                </a:solidFill>
+                <a:latin typeface="Microsoft YaHei"/>
+              </a:rPr>
+              <a:t>Step 3｜stitch-designer 生成：每个页面只调用一次生成，避免重复草稿污染项目</a:t>
+            </a:r>
+          </a:p>
+          <a:p>
+            <a:pPr>
+              <a:spcAft>
+                <a:spcPts val="1400"/>
+              </a:spcAft>
+            </a:pPr>
+            <a:r>
+              <a:rPr sz="2100">
+                <a:solidFill>
+                  <a:srgbClr val="2C3440"/>
+                </a:solidFill>
+                <a:latin typeface="Microsoft YaHei"/>
+              </a:rPr>
+              <a:t>Step 4｜截图发 Boss：统一高清截图，让 Boss 基于视觉结果确认，不在口头描述里反复来回</a:t>
+            </a:r>
+          </a:p>
+          <a:p>
+            <a:pPr>
+              <a:spcAft>
+                <a:spcPts val="1400"/>
+              </a:spcAft>
+            </a:pPr>
+            <a:r>
+              <a:rPr sz="2100">
+                <a:solidFill>
+                  <a:srgbClr val="2C3440"/>
+                </a:solidFill>
+                <a:latin typeface="Microsoft YaHei"/>
+              </a:rPr>
+              <a:t>Step 5｜反馈迭代：优先 edit_screens 做修改，不随便重新 generate</a:t>
+            </a:r>
+          </a:p>
+          <a:p>
+            <a:pPr>
+              <a:spcAft>
+                <a:spcPts val="1400"/>
+              </a:spcAft>
+            </a:pPr>
+            <a:r>
+              <a:rPr sz="2100">
+                <a:solidFill>
+                  <a:srgbClr val="2C3440"/>
+                </a:solidFill>
+                <a:latin typeface="Microsoft YaHei"/>
+              </a:rPr>
+              <a:t>Step 6｜Boss 确认后：再生成 DESIGN.md，并下载 HTML 交棒工程阶段</a:t>
+            </a:r>
+          </a:p>
+        </p:txBody>
+      </p:sp>
+      <p:sp>
+        <p:nvSpPr>
+          <p:cNvPr id="9" name="TextBox 8"/>
+          <p:cNvSpPr txBox="1"/>
+          <p:nvPr/>
+        </p:nvSpPr>
+        <p:spPr>
+          <a:xfrm>
+            <a:off x="713232" y="7223760"/>
+            <a:ext cx="10698480" cy="365760"/>
+          </a:xfrm>
+          <a:prstGeom prst="rect">
+            <a:avLst/>
+          </a:prstGeom>
+          <a:noFill/>
+        </p:spPr>
+        <p:txBody>
+          <a:bodyPr wrap="none">
+            <a:spAutoFit/>
+          </a:bodyPr>
+          <a:lstStyle/>
+          <a:p>
+            <a:r>
+              <a:rPr sz="1200" i="1">
+                <a:solidFill>
+                  <a:srgbClr val="2476FF"/>
+                </a:solidFill>
+                <a:latin typeface="Microsoft YaHei"/>
+              </a:rPr>
+              <a:t>原则：设计先闭环，工程后启动</a:t>
+            </a:r>
+          </a:p>
+        </p:txBody>
+      </p:sp>
     </p:spTree>
   </p:cSld>
   <p:clrMapOvr>
@@ -3255,6 +4663,14 @@
 <file path=ppt/slides/slide5.xml><?xml version="1.0" encoding="utf-8"?>
 <p:sld xmlns:a="http://schemas.openxmlformats.org/drawingml/2006/main" xmlns:p="http://schemas.openxmlformats.org/presentationml/2006/main" xmlns:r="http://schemas.openxmlformats.org/officeDocument/2006/relationships">
   <p:cSld>
+    <p:bg>
+      <p:bgPr>
+        <a:solidFill>
+          <a:srgbClr val="F6F7FB"/>
+        </a:solidFill>
+        <a:effectLst/>
+      </p:bgPr>
+    </p:bg>
     <p:spTree>
       <p:nvGrpSpPr>
         <p:cNvPr id="1" name=""/>
@@ -3262,30 +4678,378 @@
         <p:nvPr/>
       </p:nvGrpSpPr>
       <p:grpSpPr/>
-      <p:pic>
-        <p:nvPicPr>
-          <p:cNvPr id="2" name="Picture 1" descr="image.png"/>
-          <p:cNvPicPr>
-            <a:picLocks noChangeAspect="1"/>
-          </p:cNvPicPr>
+      <p:sp>
+        <p:nvSpPr>
+          <p:cNvPr id="2" name="Rectangle 1"/>
+          <p:cNvSpPr/>
           <p:nvPr/>
-        </p:nvPicPr>
-        <p:blipFill>
-          <a:blip r:embed="rId2"/>
-          <a:stretch>
-            <a:fillRect/>
-          </a:stretch>
-        </p:blipFill>
+        </p:nvSpPr>
         <p:spPr>
           <a:xfrm>
             <a:off x="0" y="0"/>
-            <a:ext cx="18288000" cy="10287000"/>
+            <a:ext cx="12191695" cy="502920"/>
           </a:xfrm>
           <a:prstGeom prst="rect">
             <a:avLst/>
           </a:prstGeom>
-        </p:spPr>
-      </p:pic>
+          <a:solidFill>
+            <a:srgbClr val="16213E"/>
+          </a:solidFill>
+          <a:ln>
+            <a:noFill/>
+          </a:ln>
+        </p:spPr>
+        <p:style>
+          <a:lnRef idx="1">
+            <a:schemeClr val="accent1"/>
+          </a:lnRef>
+          <a:fillRef idx="3">
+            <a:schemeClr val="accent1"/>
+          </a:fillRef>
+          <a:effectRef idx="2">
+            <a:schemeClr val="accent1"/>
+          </a:effectRef>
+          <a:fontRef idx="minor">
+            <a:schemeClr val="lt1"/>
+          </a:fontRef>
+        </p:style>
+        <p:txBody>
+          <a:bodyPr rtlCol="0" anchor="ctr"/>
+          <a:lstStyle/>
+          <a:p>
+            <a:pPr algn="ctr"/>
+          </a:p>
+        </p:txBody>
+      </p:sp>
+      <p:sp>
+        <p:nvSpPr>
+          <p:cNvPr id="3" name="TextBox 2"/>
+          <p:cNvSpPr txBox="1"/>
+          <p:nvPr/>
+        </p:nvSpPr>
+        <p:spPr>
+          <a:xfrm>
+            <a:off x="685800" y="822960"/>
+            <a:ext cx="9875520" cy="731520"/>
+          </a:xfrm>
+          <a:prstGeom prst="rect">
+            <a:avLst/>
+          </a:prstGeom>
+          <a:noFill/>
+        </p:spPr>
+        <p:txBody>
+          <a:bodyPr wrap="none">
+            <a:spAutoFit/>
+          </a:bodyPr>
+          <a:lstStyle/>
+          <a:p>
+            <a:r>
+              <a:rPr sz="2600" b="1">
+                <a:solidFill>
+                  <a:srgbClr val="16213E"/>
+                </a:solidFill>
+                <a:latin typeface="Microsoft YaHei"/>
+              </a:rPr>
+              <a:t>每个 Skill 的交付物是什么</a:t>
+            </a:r>
+          </a:p>
+        </p:txBody>
+      </p:sp>
+      <p:sp>
+        <p:nvSpPr>
+          <p:cNvPr id="4" name="Rectangle 3"/>
+          <p:cNvSpPr/>
+          <p:nvPr/>
+        </p:nvSpPr>
+        <p:spPr>
+          <a:xfrm>
+            <a:off x="10012680" y="841248"/>
+            <a:ext cx="1463040" cy="384048"/>
+          </a:xfrm>
+          <a:prstGeom prst="rect">
+            <a:avLst/>
+          </a:prstGeom>
+          <a:solidFill>
+            <a:srgbClr val="2476FF"/>
+          </a:solidFill>
+          <a:ln>
+            <a:noFill/>
+          </a:ln>
+        </p:spPr>
+        <p:style>
+          <a:lnRef idx="1">
+            <a:schemeClr val="accent1"/>
+          </a:lnRef>
+          <a:fillRef idx="3">
+            <a:schemeClr val="accent1"/>
+          </a:fillRef>
+          <a:effectRef idx="2">
+            <a:schemeClr val="accent1"/>
+          </a:effectRef>
+          <a:fontRef idx="minor">
+            <a:schemeClr val="lt1"/>
+          </a:fontRef>
+        </p:style>
+        <p:txBody>
+          <a:bodyPr rtlCol="0" anchor="ctr"/>
+          <a:lstStyle/>
+          <a:p>
+            <a:pPr algn="ctr"/>
+            <a:r>
+              <a:rPr sz="1300" b="1">
+                <a:solidFill>
+                  <a:srgbClr val="FFFFFF"/>
+                </a:solidFill>
+                <a:latin typeface="Microsoft YaHei"/>
+              </a:rPr>
+              <a:t>第 5 页</a:t>
+            </a:r>
+          </a:p>
+        </p:txBody>
+      </p:sp>
+      <p:sp>
+        <p:nvSpPr>
+          <p:cNvPr id="5" name="TextBox 4"/>
+          <p:cNvSpPr txBox="1"/>
+          <p:nvPr/>
+        </p:nvSpPr>
+        <p:spPr>
+          <a:xfrm>
+            <a:off x="713232" y="1508760"/>
+            <a:ext cx="10698480" cy="502920"/>
+          </a:xfrm>
+          <a:prstGeom prst="rect">
+            <a:avLst/>
+          </a:prstGeom>
+          <a:noFill/>
+        </p:spPr>
+        <p:txBody>
+          <a:bodyPr wrap="none">
+            <a:spAutoFit/>
+          </a:bodyPr>
+          <a:lstStyle/>
+          <a:p>
+            <a:r>
+              <a:rPr sz="1400">
+                <a:solidFill>
+                  <a:srgbClr val="687282"/>
+                </a:solidFill>
+                <a:latin typeface="Microsoft YaHei"/>
+              </a:rPr>
+              <a:t>围绕 Stitch skill 的职责、顺序、交付物，把 MiniseLab 的设计协作流程讲清楚。</a:t>
+            </a:r>
+          </a:p>
+        </p:txBody>
+      </p:sp>
+      <p:sp>
+        <p:nvSpPr>
+          <p:cNvPr id="6" name="Rectangle 5"/>
+          <p:cNvSpPr/>
+          <p:nvPr/>
+        </p:nvSpPr>
+        <p:spPr>
+          <a:xfrm>
+            <a:off x="658368" y="1920240"/>
+            <a:ext cx="10881360" cy="5074920"/>
+          </a:xfrm>
+          <a:prstGeom prst="rect">
+            <a:avLst/>
+          </a:prstGeom>
+          <a:solidFill>
+            <a:srgbClr val="FFFFFF"/>
+          </a:solidFill>
+          <a:ln w="12700">
+            <a:solidFill>
+              <a:srgbClr val="DDE2EE"/>
+            </a:solidFill>
+          </a:ln>
+        </p:spPr>
+        <p:style>
+          <a:lnRef idx="1">
+            <a:schemeClr val="accent1"/>
+          </a:lnRef>
+          <a:fillRef idx="3">
+            <a:schemeClr val="accent1"/>
+          </a:fillRef>
+          <a:effectRef idx="2">
+            <a:schemeClr val="accent1"/>
+          </a:effectRef>
+          <a:fontRef idx="minor">
+            <a:schemeClr val="lt1"/>
+          </a:fontRef>
+        </p:style>
+        <p:txBody>
+          <a:bodyPr rtlCol="0" anchor="ctr"/>
+          <a:lstStyle/>
+          <a:p>
+            <a:pPr algn="ctr"/>
+          </a:p>
+        </p:txBody>
+      </p:sp>
+      <p:sp>
+        <p:nvSpPr>
+          <p:cNvPr id="7" name="Rectangle 6"/>
+          <p:cNvSpPr/>
+          <p:nvPr/>
+        </p:nvSpPr>
+        <p:spPr>
+          <a:xfrm>
+            <a:off x="822960" y="2148840"/>
+            <a:ext cx="109728" cy="4526280"/>
+          </a:xfrm>
+          <a:prstGeom prst="rect">
+            <a:avLst/>
+          </a:prstGeom>
+          <a:solidFill>
+            <a:srgbClr val="2476FF"/>
+          </a:solidFill>
+          <a:ln>
+            <a:noFill/>
+          </a:ln>
+        </p:spPr>
+        <p:style>
+          <a:lnRef idx="1">
+            <a:schemeClr val="accent1"/>
+          </a:lnRef>
+          <a:fillRef idx="3">
+            <a:schemeClr val="accent1"/>
+          </a:fillRef>
+          <a:effectRef idx="2">
+            <a:schemeClr val="accent1"/>
+          </a:effectRef>
+          <a:fontRef idx="minor">
+            <a:schemeClr val="lt1"/>
+          </a:fontRef>
+        </p:style>
+        <p:txBody>
+          <a:bodyPr rtlCol="0" anchor="ctr"/>
+          <a:lstStyle/>
+          <a:p>
+            <a:pPr algn="ctr"/>
+          </a:p>
+        </p:txBody>
+      </p:sp>
+      <p:sp>
+        <p:nvSpPr>
+          <p:cNvPr id="8" name="TextBox 7"/>
+          <p:cNvSpPr txBox="1"/>
+          <p:nvPr/>
+        </p:nvSpPr>
+        <p:spPr>
+          <a:xfrm>
+            <a:off x="1078992" y="2148840"/>
+            <a:ext cx="9966960" cy="4434840"/>
+          </a:xfrm>
+          <a:prstGeom prst="rect">
+            <a:avLst/>
+          </a:prstGeom>
+          <a:noFill/>
+        </p:spPr>
+        <p:txBody>
+          <a:bodyPr wrap="square">
+            <a:spAutoFit/>
+          </a:bodyPr>
+          <a:lstStyle/>
+          <a:p>
+            <a:pPr>
+              <a:spcAft>
+                <a:spcPts val="1400"/>
+              </a:spcAft>
+            </a:pPr>
+            <a:r>
+              <a:rPr sz="2100">
+                <a:solidFill>
+                  <a:srgbClr val="2C3440"/>
+                </a:solidFill>
+                <a:latin typeface="Microsoft YaHei"/>
+              </a:rPr>
+              <a:t>enhance-prompt 的输出：高质量 prompt 文本。它不产页面，但决定页面质量上限</a:t>
+            </a:r>
+          </a:p>
+          <a:p>
+            <a:pPr>
+              <a:spcAft>
+                <a:spcPts val="1400"/>
+              </a:spcAft>
+            </a:pPr>
+            <a:r>
+              <a:rPr sz="2100">
+                <a:solidFill>
+                  <a:srgbClr val="2C3440"/>
+                </a:solidFill>
+                <a:latin typeface="Microsoft YaHei"/>
+              </a:rPr>
+              <a:t>stitch-designer 的输出：Stitch 项目、screen、截图、HTML 下载链接、.stitch/metadata.json</a:t>
+            </a:r>
+          </a:p>
+          <a:p>
+            <a:pPr>
+              <a:spcAft>
+                <a:spcPts val="1400"/>
+              </a:spcAft>
+            </a:pPr>
+            <a:r>
+              <a:rPr sz="2100">
+                <a:solidFill>
+                  <a:srgbClr val="2C3440"/>
+                </a:solidFill>
+                <a:latin typeface="Microsoft YaHei"/>
+              </a:rPr>
+              <a:t>design-md 的输出：DESIGN.md，把颜色、字体、组件风格、布局规律沉淀下来</a:t>
+            </a:r>
+          </a:p>
+          <a:p>
+            <a:pPr>
+              <a:spcAft>
+                <a:spcPts val="1400"/>
+              </a:spcAft>
+            </a:pPr>
+            <a:r>
+              <a:rPr sz="2100">
+                <a:solidFill>
+                  <a:srgbClr val="2C3440"/>
+                </a:solidFill>
+                <a:latin typeface="Microsoft YaHei"/>
+              </a:rPr>
+              <a:t>stitch-frontend（下一阶段）的输入：已经确认过的 HTML + DESIGN.md；它负责 1:1 手写还原成 React 工程，不负责重新设计</a:t>
+            </a:r>
+          </a:p>
+        </p:txBody>
+      </p:sp>
+      <p:sp>
+        <p:nvSpPr>
+          <p:cNvPr id="9" name="TextBox 8"/>
+          <p:cNvSpPr txBox="1"/>
+          <p:nvPr/>
+        </p:nvSpPr>
+        <p:spPr>
+          <a:xfrm>
+            <a:off x="713232" y="7223760"/>
+            <a:ext cx="10698480" cy="365760"/>
+          </a:xfrm>
+          <a:prstGeom prst="rect">
+            <a:avLst/>
+          </a:prstGeom>
+          <a:noFill/>
+        </p:spPr>
+        <p:txBody>
+          <a:bodyPr wrap="none">
+            <a:spAutoFit/>
+          </a:bodyPr>
+          <a:lstStyle/>
+          <a:p>
+            <a:r>
+              <a:rPr sz="1200" i="1">
+                <a:solidFill>
+                  <a:srgbClr val="2476FF"/>
+                </a:solidFill>
+                <a:latin typeface="Microsoft YaHei"/>
+              </a:rPr>
+              <a:t>交付物清楚，协作边界才不会乱</a:t>
+            </a:r>
+          </a:p>
+        </p:txBody>
+      </p:sp>
     </p:spTree>
   </p:cSld>
   <p:clrMapOvr>
@@ -3297,6 +5061,14 @@
 <file path=ppt/slides/slide6.xml><?xml version="1.0" encoding="utf-8"?>
 <p:sld xmlns:a="http://schemas.openxmlformats.org/drawingml/2006/main" xmlns:p="http://schemas.openxmlformats.org/presentationml/2006/main" xmlns:r="http://schemas.openxmlformats.org/officeDocument/2006/relationships">
   <p:cSld>
+    <p:bg>
+      <p:bgPr>
+        <a:solidFill>
+          <a:srgbClr val="F6F7FB"/>
+        </a:solidFill>
+        <a:effectLst/>
+      </p:bgPr>
+    </p:bg>
     <p:spTree>
       <p:nvGrpSpPr>
         <p:cNvPr id="1" name=""/>
@@ -3304,30 +5076,394 @@
         <p:nvPr/>
       </p:nvGrpSpPr>
       <p:grpSpPr/>
-      <p:pic>
-        <p:nvPicPr>
-          <p:cNvPr id="2" name="Picture 1" descr="image.png"/>
-          <p:cNvPicPr>
-            <a:picLocks noChangeAspect="1"/>
-          </p:cNvPicPr>
+      <p:sp>
+        <p:nvSpPr>
+          <p:cNvPr id="2" name="Rectangle 1"/>
+          <p:cNvSpPr/>
           <p:nvPr/>
-        </p:nvPicPr>
-        <p:blipFill>
-          <a:blip r:embed="rId2"/>
-          <a:stretch>
-            <a:fillRect/>
-          </a:stretch>
-        </p:blipFill>
+        </p:nvSpPr>
         <p:spPr>
           <a:xfrm>
             <a:off x="0" y="0"/>
-            <a:ext cx="18288000" cy="10287000"/>
+            <a:ext cx="12191695" cy="502920"/>
           </a:xfrm>
           <a:prstGeom prst="rect">
             <a:avLst/>
           </a:prstGeom>
-        </p:spPr>
-      </p:pic>
+          <a:solidFill>
+            <a:srgbClr val="16213E"/>
+          </a:solidFill>
+          <a:ln>
+            <a:noFill/>
+          </a:ln>
+        </p:spPr>
+        <p:style>
+          <a:lnRef idx="1">
+            <a:schemeClr val="accent1"/>
+          </a:lnRef>
+          <a:fillRef idx="3">
+            <a:schemeClr val="accent1"/>
+          </a:fillRef>
+          <a:effectRef idx="2">
+            <a:schemeClr val="accent1"/>
+          </a:effectRef>
+          <a:fontRef idx="minor">
+            <a:schemeClr val="lt1"/>
+          </a:fontRef>
+        </p:style>
+        <p:txBody>
+          <a:bodyPr rtlCol="0" anchor="ctr"/>
+          <a:lstStyle/>
+          <a:p>
+            <a:pPr algn="ctr"/>
+          </a:p>
+        </p:txBody>
+      </p:sp>
+      <p:sp>
+        <p:nvSpPr>
+          <p:cNvPr id="3" name="TextBox 2"/>
+          <p:cNvSpPr txBox="1"/>
+          <p:nvPr/>
+        </p:nvSpPr>
+        <p:spPr>
+          <a:xfrm>
+            <a:off x="685800" y="822960"/>
+            <a:ext cx="9875520" cy="731520"/>
+          </a:xfrm>
+          <a:prstGeom prst="rect">
+            <a:avLst/>
+          </a:prstGeom>
+          <a:noFill/>
+        </p:spPr>
+        <p:txBody>
+          <a:bodyPr wrap="none">
+            <a:spAutoFit/>
+          </a:bodyPr>
+          <a:lstStyle/>
+          <a:p>
+            <a:r>
+              <a:rPr sz="2600" b="1">
+                <a:solidFill>
+                  <a:srgbClr val="16213E"/>
+                </a:solidFill>
+                <a:latin typeface="Microsoft YaHei"/>
+              </a:rPr>
+              <a:t>为什么这套流程更稳</a:t>
+            </a:r>
+          </a:p>
+        </p:txBody>
+      </p:sp>
+      <p:sp>
+        <p:nvSpPr>
+          <p:cNvPr id="4" name="Rectangle 3"/>
+          <p:cNvSpPr/>
+          <p:nvPr/>
+        </p:nvSpPr>
+        <p:spPr>
+          <a:xfrm>
+            <a:off x="10012680" y="841248"/>
+            <a:ext cx="1463040" cy="384048"/>
+          </a:xfrm>
+          <a:prstGeom prst="rect">
+            <a:avLst/>
+          </a:prstGeom>
+          <a:solidFill>
+            <a:srgbClr val="2476FF"/>
+          </a:solidFill>
+          <a:ln>
+            <a:noFill/>
+          </a:ln>
+        </p:spPr>
+        <p:style>
+          <a:lnRef idx="1">
+            <a:schemeClr val="accent1"/>
+          </a:lnRef>
+          <a:fillRef idx="3">
+            <a:schemeClr val="accent1"/>
+          </a:fillRef>
+          <a:effectRef idx="2">
+            <a:schemeClr val="accent1"/>
+          </a:effectRef>
+          <a:fontRef idx="minor">
+            <a:schemeClr val="lt1"/>
+          </a:fontRef>
+        </p:style>
+        <p:txBody>
+          <a:bodyPr rtlCol="0" anchor="ctr"/>
+          <a:lstStyle/>
+          <a:p>
+            <a:pPr algn="ctr"/>
+            <a:r>
+              <a:rPr sz="1300" b="1">
+                <a:solidFill>
+                  <a:srgbClr val="FFFFFF"/>
+                </a:solidFill>
+                <a:latin typeface="Microsoft YaHei"/>
+              </a:rPr>
+              <a:t>第 6 页</a:t>
+            </a:r>
+          </a:p>
+        </p:txBody>
+      </p:sp>
+      <p:sp>
+        <p:nvSpPr>
+          <p:cNvPr id="5" name="TextBox 4"/>
+          <p:cNvSpPr txBox="1"/>
+          <p:nvPr/>
+        </p:nvSpPr>
+        <p:spPr>
+          <a:xfrm>
+            <a:off x="713232" y="1508760"/>
+            <a:ext cx="10698480" cy="502920"/>
+          </a:xfrm>
+          <a:prstGeom prst="rect">
+            <a:avLst/>
+          </a:prstGeom>
+          <a:noFill/>
+        </p:spPr>
+        <p:txBody>
+          <a:bodyPr wrap="none">
+            <a:spAutoFit/>
+          </a:bodyPr>
+          <a:lstStyle/>
+          <a:p>
+            <a:r>
+              <a:rPr sz="1400">
+                <a:solidFill>
+                  <a:srgbClr val="687282"/>
+                </a:solidFill>
+                <a:latin typeface="Microsoft YaHei"/>
+              </a:rPr>
+              <a:t>围绕 Stitch skill 的职责、顺序、交付物，把 MiniseLab 的设计协作流程讲清楚。</a:t>
+            </a:r>
+          </a:p>
+        </p:txBody>
+      </p:sp>
+      <p:sp>
+        <p:nvSpPr>
+          <p:cNvPr id="6" name="Rectangle 5"/>
+          <p:cNvSpPr/>
+          <p:nvPr/>
+        </p:nvSpPr>
+        <p:spPr>
+          <a:xfrm>
+            <a:off x="658368" y="1920240"/>
+            <a:ext cx="10881360" cy="5074920"/>
+          </a:xfrm>
+          <a:prstGeom prst="rect">
+            <a:avLst/>
+          </a:prstGeom>
+          <a:solidFill>
+            <a:srgbClr val="FFFFFF"/>
+          </a:solidFill>
+          <a:ln w="12700">
+            <a:solidFill>
+              <a:srgbClr val="DDE2EE"/>
+            </a:solidFill>
+          </a:ln>
+        </p:spPr>
+        <p:style>
+          <a:lnRef idx="1">
+            <a:schemeClr val="accent1"/>
+          </a:lnRef>
+          <a:fillRef idx="3">
+            <a:schemeClr val="accent1"/>
+          </a:fillRef>
+          <a:effectRef idx="2">
+            <a:schemeClr val="accent1"/>
+          </a:effectRef>
+          <a:fontRef idx="minor">
+            <a:schemeClr val="lt1"/>
+          </a:fontRef>
+        </p:style>
+        <p:txBody>
+          <a:bodyPr rtlCol="0" anchor="ctr"/>
+          <a:lstStyle/>
+          <a:p>
+            <a:pPr algn="ctr"/>
+          </a:p>
+        </p:txBody>
+      </p:sp>
+      <p:sp>
+        <p:nvSpPr>
+          <p:cNvPr id="7" name="Rectangle 6"/>
+          <p:cNvSpPr/>
+          <p:nvPr/>
+        </p:nvSpPr>
+        <p:spPr>
+          <a:xfrm>
+            <a:off x="822960" y="2148840"/>
+            <a:ext cx="109728" cy="4526280"/>
+          </a:xfrm>
+          <a:prstGeom prst="rect">
+            <a:avLst/>
+          </a:prstGeom>
+          <a:solidFill>
+            <a:srgbClr val="2476FF"/>
+          </a:solidFill>
+          <a:ln>
+            <a:noFill/>
+          </a:ln>
+        </p:spPr>
+        <p:style>
+          <a:lnRef idx="1">
+            <a:schemeClr val="accent1"/>
+          </a:lnRef>
+          <a:fillRef idx="3">
+            <a:schemeClr val="accent1"/>
+          </a:fillRef>
+          <a:effectRef idx="2">
+            <a:schemeClr val="accent1"/>
+          </a:effectRef>
+          <a:fontRef idx="minor">
+            <a:schemeClr val="lt1"/>
+          </a:fontRef>
+        </p:style>
+        <p:txBody>
+          <a:bodyPr rtlCol="0" anchor="ctr"/>
+          <a:lstStyle/>
+          <a:p>
+            <a:pPr algn="ctr"/>
+          </a:p>
+        </p:txBody>
+      </p:sp>
+      <p:sp>
+        <p:nvSpPr>
+          <p:cNvPr id="8" name="TextBox 7"/>
+          <p:cNvSpPr txBox="1"/>
+          <p:nvPr/>
+        </p:nvSpPr>
+        <p:spPr>
+          <a:xfrm>
+            <a:off x="1078992" y="2148840"/>
+            <a:ext cx="9966960" cy="4434840"/>
+          </a:xfrm>
+          <a:prstGeom prst="rect">
+            <a:avLst/>
+          </a:prstGeom>
+          <a:noFill/>
+        </p:spPr>
+        <p:txBody>
+          <a:bodyPr wrap="square">
+            <a:spAutoFit/>
+          </a:bodyPr>
+          <a:lstStyle/>
+          <a:p>
+            <a:pPr>
+              <a:spcAft>
+                <a:spcPts val="1400"/>
+              </a:spcAft>
+            </a:pPr>
+            <a:r>
+              <a:rPr sz="2100">
+                <a:solidFill>
+                  <a:srgbClr val="2C3440"/>
+                </a:solidFill>
+                <a:latin typeface="Microsoft YaHei"/>
+              </a:rPr>
+              <a:t>减少返工：先让 Boss 看图确认，再做工程，避免“代码写完才说不像”</a:t>
+            </a:r>
+          </a:p>
+          <a:p>
+            <a:pPr>
+              <a:spcAft>
+                <a:spcPts val="1400"/>
+              </a:spcAft>
+            </a:pPr>
+            <a:r>
+              <a:rPr sz="2100">
+                <a:solidFill>
+                  <a:srgbClr val="2C3440"/>
+                </a:solidFill>
+                <a:latin typeface="Microsoft YaHei"/>
+              </a:rPr>
+              <a:t>保证一致性：DESIGN.md 让多页面项目持续沿用同一视觉语言</a:t>
+            </a:r>
+          </a:p>
+          <a:p>
+            <a:pPr>
+              <a:spcAft>
+                <a:spcPts val="1400"/>
+              </a:spcAft>
+            </a:pPr>
+            <a:r>
+              <a:rPr sz="2100">
+                <a:solidFill>
+                  <a:srgbClr val="2C3440"/>
+                </a:solidFill>
+                <a:latin typeface="Microsoft YaHei"/>
+              </a:rPr>
+              <a:t>避免脏项目：stitch-designer 明确要求单页单次生成、优先编辑，减少重复草稿</a:t>
+            </a:r>
+          </a:p>
+          <a:p>
+            <a:pPr>
+              <a:spcAft>
+                <a:spcPts val="1400"/>
+              </a:spcAft>
+            </a:pPr>
+            <a:r>
+              <a:rPr sz="2100">
+                <a:solidFill>
+                  <a:srgbClr val="2C3440"/>
+                </a:solidFill>
+                <a:latin typeface="Microsoft YaHei"/>
+              </a:rPr>
+              <a:t>方便交棒：设计阶段产出 HTML，工程阶段按 stitch-frontend 直接 1:1 还原，路径清晰</a:t>
+            </a:r>
+          </a:p>
+          <a:p>
+            <a:pPr>
+              <a:spcAft>
+                <a:spcPts val="1400"/>
+              </a:spcAft>
+            </a:pPr>
+            <a:r>
+              <a:rPr sz="2100">
+                <a:solidFill>
+                  <a:srgbClr val="2C3440"/>
+                </a:solidFill>
+                <a:latin typeface="Microsoft YaHei"/>
+              </a:rPr>
+              <a:t>适合展示型项目：尤其适合只要 Demo、原型、提案展示，而不需要真实后端的场景</a:t>
+            </a:r>
+          </a:p>
+        </p:txBody>
+      </p:sp>
+      <p:sp>
+        <p:nvSpPr>
+          <p:cNvPr id="9" name="TextBox 8"/>
+          <p:cNvSpPr txBox="1"/>
+          <p:nvPr/>
+        </p:nvSpPr>
+        <p:spPr>
+          <a:xfrm>
+            <a:off x="713232" y="7223760"/>
+            <a:ext cx="10698480" cy="365760"/>
+          </a:xfrm>
+          <a:prstGeom prst="rect">
+            <a:avLst/>
+          </a:prstGeom>
+          <a:noFill/>
+        </p:spPr>
+        <p:txBody>
+          <a:bodyPr wrap="none">
+            <a:spAutoFit/>
+          </a:bodyPr>
+          <a:lstStyle/>
+          <a:p>
+            <a:r>
+              <a:rPr sz="1200" i="1">
+                <a:solidFill>
+                  <a:srgbClr val="2476FF"/>
+                </a:solidFill>
+                <a:latin typeface="Microsoft YaHei"/>
+              </a:rPr>
+              <a:t>一句话：把不确定性消灭在设计阶段</a:t>
+            </a:r>
+          </a:p>
+        </p:txBody>
+      </p:sp>
     </p:spTree>
   </p:cSld>
   <p:clrMapOvr>
@@ -3339,6 +5475,14 @@
 <file path=ppt/slides/slide7.xml><?xml version="1.0" encoding="utf-8"?>
 <p:sld xmlns:a="http://schemas.openxmlformats.org/drawingml/2006/main" xmlns:p="http://schemas.openxmlformats.org/presentationml/2006/main" xmlns:r="http://schemas.openxmlformats.org/officeDocument/2006/relationships">
   <p:cSld>
+    <p:bg>
+      <p:bgPr>
+        <a:solidFill>
+          <a:srgbClr val="F6F7FB"/>
+        </a:solidFill>
+        <a:effectLst/>
+      </p:bgPr>
+    </p:bg>
     <p:spTree>
       <p:nvGrpSpPr>
         <p:cNvPr id="1" name=""/>
@@ -3346,30 +5490,362 @@
         <p:nvPr/>
       </p:nvGrpSpPr>
       <p:grpSpPr/>
-      <p:pic>
-        <p:nvPicPr>
-          <p:cNvPr id="2" name="Picture 1" descr="image.png"/>
-          <p:cNvPicPr>
-            <a:picLocks noChangeAspect="1"/>
-          </p:cNvPicPr>
+      <p:sp>
+        <p:nvSpPr>
+          <p:cNvPr id="2" name="Rectangle 1"/>
+          <p:cNvSpPr/>
           <p:nvPr/>
-        </p:nvPicPr>
-        <p:blipFill>
-          <a:blip r:embed="rId2"/>
-          <a:stretch>
-            <a:fillRect/>
-          </a:stretch>
-        </p:blipFill>
+        </p:nvSpPr>
         <p:spPr>
           <a:xfrm>
             <a:off x="0" y="0"/>
-            <a:ext cx="18288000" cy="10287000"/>
+            <a:ext cx="12191695" cy="502920"/>
           </a:xfrm>
           <a:prstGeom prst="rect">
             <a:avLst/>
           </a:prstGeom>
-        </p:spPr>
-      </p:pic>
+          <a:solidFill>
+            <a:srgbClr val="16213E"/>
+          </a:solidFill>
+          <a:ln>
+            <a:noFill/>
+          </a:ln>
+        </p:spPr>
+        <p:style>
+          <a:lnRef idx="1">
+            <a:schemeClr val="accent1"/>
+          </a:lnRef>
+          <a:fillRef idx="3">
+            <a:schemeClr val="accent1"/>
+          </a:fillRef>
+          <a:effectRef idx="2">
+            <a:schemeClr val="accent1"/>
+          </a:effectRef>
+          <a:fontRef idx="minor">
+            <a:schemeClr val="lt1"/>
+          </a:fontRef>
+        </p:style>
+        <p:txBody>
+          <a:bodyPr rtlCol="0" anchor="ctr"/>
+          <a:lstStyle/>
+          <a:p>
+            <a:pPr algn="ctr"/>
+          </a:p>
+        </p:txBody>
+      </p:sp>
+      <p:sp>
+        <p:nvSpPr>
+          <p:cNvPr id="3" name="TextBox 2"/>
+          <p:cNvSpPr txBox="1"/>
+          <p:nvPr/>
+        </p:nvSpPr>
+        <p:spPr>
+          <a:xfrm>
+            <a:off x="685800" y="822960"/>
+            <a:ext cx="9875520" cy="731520"/>
+          </a:xfrm>
+          <a:prstGeom prst="rect">
+            <a:avLst/>
+          </a:prstGeom>
+          <a:noFill/>
+        </p:spPr>
+        <p:txBody>
+          <a:bodyPr wrap="none">
+            <a:spAutoFit/>
+          </a:bodyPr>
+          <a:lstStyle/>
+          <a:p>
+            <a:r>
+              <a:rPr sz="2600" b="1">
+                <a:solidFill>
+                  <a:srgbClr val="16213E"/>
+                </a:solidFill>
+                <a:latin typeface="Microsoft YaHei"/>
+              </a:rPr>
+              <a:t>给 Boss 的一句话版本</a:t>
+            </a:r>
+          </a:p>
+        </p:txBody>
+      </p:sp>
+      <p:sp>
+        <p:nvSpPr>
+          <p:cNvPr id="4" name="Rectangle 3"/>
+          <p:cNvSpPr/>
+          <p:nvPr/>
+        </p:nvSpPr>
+        <p:spPr>
+          <a:xfrm>
+            <a:off x="10012680" y="841248"/>
+            <a:ext cx="1463040" cy="384048"/>
+          </a:xfrm>
+          <a:prstGeom prst="rect">
+            <a:avLst/>
+          </a:prstGeom>
+          <a:solidFill>
+            <a:srgbClr val="2476FF"/>
+          </a:solidFill>
+          <a:ln>
+            <a:noFill/>
+          </a:ln>
+        </p:spPr>
+        <p:style>
+          <a:lnRef idx="1">
+            <a:schemeClr val="accent1"/>
+          </a:lnRef>
+          <a:fillRef idx="3">
+            <a:schemeClr val="accent1"/>
+          </a:fillRef>
+          <a:effectRef idx="2">
+            <a:schemeClr val="accent1"/>
+          </a:effectRef>
+          <a:fontRef idx="minor">
+            <a:schemeClr val="lt1"/>
+          </a:fontRef>
+        </p:style>
+        <p:txBody>
+          <a:bodyPr rtlCol="0" anchor="ctr"/>
+          <a:lstStyle/>
+          <a:p>
+            <a:pPr algn="ctr"/>
+            <a:r>
+              <a:rPr sz="1300" b="1">
+                <a:solidFill>
+                  <a:srgbClr val="FFFFFF"/>
+                </a:solidFill>
+                <a:latin typeface="Microsoft YaHei"/>
+              </a:rPr>
+              <a:t>第 7 页</a:t>
+            </a:r>
+          </a:p>
+        </p:txBody>
+      </p:sp>
+      <p:sp>
+        <p:nvSpPr>
+          <p:cNvPr id="5" name="TextBox 4"/>
+          <p:cNvSpPr txBox="1"/>
+          <p:nvPr/>
+        </p:nvSpPr>
+        <p:spPr>
+          <a:xfrm>
+            <a:off x="713232" y="1508760"/>
+            <a:ext cx="10698480" cy="502920"/>
+          </a:xfrm>
+          <a:prstGeom prst="rect">
+            <a:avLst/>
+          </a:prstGeom>
+          <a:noFill/>
+        </p:spPr>
+        <p:txBody>
+          <a:bodyPr wrap="none">
+            <a:spAutoFit/>
+          </a:bodyPr>
+          <a:lstStyle/>
+          <a:p>
+            <a:r>
+              <a:rPr sz="1400">
+                <a:solidFill>
+                  <a:srgbClr val="687282"/>
+                </a:solidFill>
+                <a:latin typeface="Microsoft YaHei"/>
+              </a:rPr>
+              <a:t>围绕 Stitch skill 的职责、顺序、交付物，把 MiniseLab 的设计协作流程讲清楚。</a:t>
+            </a:r>
+          </a:p>
+        </p:txBody>
+      </p:sp>
+      <p:sp>
+        <p:nvSpPr>
+          <p:cNvPr id="6" name="Rectangle 5"/>
+          <p:cNvSpPr/>
+          <p:nvPr/>
+        </p:nvSpPr>
+        <p:spPr>
+          <a:xfrm>
+            <a:off x="658368" y="1920240"/>
+            <a:ext cx="10881360" cy="5074920"/>
+          </a:xfrm>
+          <a:prstGeom prst="rect">
+            <a:avLst/>
+          </a:prstGeom>
+          <a:solidFill>
+            <a:srgbClr val="FFFFFF"/>
+          </a:solidFill>
+          <a:ln w="12700">
+            <a:solidFill>
+              <a:srgbClr val="DDE2EE"/>
+            </a:solidFill>
+          </a:ln>
+        </p:spPr>
+        <p:style>
+          <a:lnRef idx="1">
+            <a:schemeClr val="accent1"/>
+          </a:lnRef>
+          <a:fillRef idx="3">
+            <a:schemeClr val="accent1"/>
+          </a:fillRef>
+          <a:effectRef idx="2">
+            <a:schemeClr val="accent1"/>
+          </a:effectRef>
+          <a:fontRef idx="minor">
+            <a:schemeClr val="lt1"/>
+          </a:fontRef>
+        </p:style>
+        <p:txBody>
+          <a:bodyPr rtlCol="0" anchor="ctr"/>
+          <a:lstStyle/>
+          <a:p>
+            <a:pPr algn="ctr"/>
+          </a:p>
+        </p:txBody>
+      </p:sp>
+      <p:sp>
+        <p:nvSpPr>
+          <p:cNvPr id="7" name="Rectangle 6"/>
+          <p:cNvSpPr/>
+          <p:nvPr/>
+        </p:nvSpPr>
+        <p:spPr>
+          <a:xfrm>
+            <a:off x="822960" y="2148840"/>
+            <a:ext cx="109728" cy="4526280"/>
+          </a:xfrm>
+          <a:prstGeom prst="rect">
+            <a:avLst/>
+          </a:prstGeom>
+          <a:solidFill>
+            <a:srgbClr val="2476FF"/>
+          </a:solidFill>
+          <a:ln>
+            <a:noFill/>
+          </a:ln>
+        </p:spPr>
+        <p:style>
+          <a:lnRef idx="1">
+            <a:schemeClr val="accent1"/>
+          </a:lnRef>
+          <a:fillRef idx="3">
+            <a:schemeClr val="accent1"/>
+          </a:fillRef>
+          <a:effectRef idx="2">
+            <a:schemeClr val="accent1"/>
+          </a:effectRef>
+          <a:fontRef idx="minor">
+            <a:schemeClr val="lt1"/>
+          </a:fontRef>
+        </p:style>
+        <p:txBody>
+          <a:bodyPr rtlCol="0" anchor="ctr"/>
+          <a:lstStyle/>
+          <a:p>
+            <a:pPr algn="ctr"/>
+          </a:p>
+        </p:txBody>
+      </p:sp>
+      <p:sp>
+        <p:nvSpPr>
+          <p:cNvPr id="8" name="TextBox 7"/>
+          <p:cNvSpPr txBox="1"/>
+          <p:nvPr/>
+        </p:nvSpPr>
+        <p:spPr>
+          <a:xfrm>
+            <a:off x="1078992" y="2148840"/>
+            <a:ext cx="9966960" cy="4434840"/>
+          </a:xfrm>
+          <a:prstGeom prst="rect">
+            <a:avLst/>
+          </a:prstGeom>
+          <a:noFill/>
+        </p:spPr>
+        <p:txBody>
+          <a:bodyPr wrap="square">
+            <a:spAutoFit/>
+          </a:bodyPr>
+          <a:lstStyle/>
+          <a:p>
+            <a:pPr>
+              <a:spcAft>
+                <a:spcPts val="1400"/>
+              </a:spcAft>
+            </a:pPr>
+            <a:r>
+              <a:rPr sz="2400">
+                <a:solidFill>
+                  <a:srgbClr val="2C3440"/>
+                </a:solidFill>
+                <a:latin typeface="Microsoft YaHei"/>
+              </a:rPr>
+              <a:t>如果是 UI / 页面 / 原型需求：先走 Stitch 设计链路，不直接开写前端</a:t>
+            </a:r>
+          </a:p>
+          <a:p>
+            <a:pPr>
+              <a:spcAft>
+                <a:spcPts val="1400"/>
+              </a:spcAft>
+            </a:pPr>
+            <a:r>
+              <a:rPr sz="2400">
+                <a:solidFill>
+                  <a:srgbClr val="2C3440"/>
+                </a:solidFill>
+                <a:latin typeface="Microsoft YaHei"/>
+              </a:rPr>
+              <a:t>固定顺序：enhance-prompt → stitch-designer → design-md → Boss 确认 → stitch-frontend</a:t>
+            </a:r>
+          </a:p>
+          <a:p>
+            <a:pPr>
+              <a:spcAft>
+                <a:spcPts val="1400"/>
+              </a:spcAft>
+            </a:pPr>
+            <a:r>
+              <a:rPr sz="2400">
+                <a:solidFill>
+                  <a:srgbClr val="2C3440"/>
+                </a:solidFill>
+                <a:latin typeface="Microsoft YaHei"/>
+              </a:rPr>
+              <a:t>这样做的结果是：看得见、改得快、风格统一、工程还原不跑偏</a:t>
+            </a:r>
+          </a:p>
+        </p:txBody>
+      </p:sp>
+      <p:sp>
+        <p:nvSpPr>
+          <p:cNvPr id="9" name="TextBox 8"/>
+          <p:cNvSpPr txBox="1"/>
+          <p:nvPr/>
+        </p:nvSpPr>
+        <p:spPr>
+          <a:xfrm>
+            <a:off x="713232" y="7223760"/>
+            <a:ext cx="10698480" cy="365760"/>
+          </a:xfrm>
+          <a:prstGeom prst="rect">
+            <a:avLst/>
+          </a:prstGeom>
+          <a:noFill/>
+        </p:spPr>
+        <p:txBody>
+          <a:bodyPr wrap="none">
+            <a:spAutoFit/>
+          </a:bodyPr>
+          <a:lstStyle/>
+          <a:p>
+            <a:r>
+              <a:rPr sz="1200" i="1">
+                <a:solidFill>
+                  <a:srgbClr val="2476FF"/>
+                </a:solidFill>
+                <a:latin typeface="Microsoft YaHei"/>
+              </a:rPr>
+              <a:t>MiniseLab：先定设计真相，再做工程落地</a:t>
+            </a:r>
+          </a:p>
+        </p:txBody>
+      </p:sp>
     </p:spTree>
   </p:cSld>
   <p:clrMapOvr>

</xml_diff>